<commit_message>
Лекция 4→7: deck-каскад (cover 07, s28 canon-true, s24a/s26 sync) #92
presentation-designer: deck.yaml lecture_number 4→7; cover «04»→«07»;
s28 переписан под новый §5.2 (number-neutral, синтез=Л17, убраны
Коллоквиум/Л6-производство/Л9-arrow); s24a/s26 тоже несли canon-
нарушения (Л6 teaser/Л14/Л9) — поправлены. 4 слайда изменены,
30 byte-identical. Перерендер pptx/pdf/snapshots. Палитра/gold OK.

Co-Authored-By: Claude Opus 4.7 (1M context) <noreply@anthropic.com>
</commit_message>
<xml_diff>
--- a/library/lectures/lec-04/rendered/lec-04.pptx
+++ b/library/lectures/lec-04/rendered/lec-04.pptx
@@ -1467,7 +1467,7 @@
           <a:lstStyle/>
           <a:p>
             <a:r>
-              <a:t>Это титульный слайд лекции. Он короткий по смыслу: курс, номер лекции, тема, длительность, дата. Шаблон визуально совпадает с другими лекциями курса — это часть continuity, к которой студент уже привык. Никакого дополнительного контента здесь нет; задача слайда — обозначить точку входа в лекцию и быстро перейти к опросу. Лектор задерживается на нём ровно столько, сколько нужно, чтобы аудитория сориентировалась, и сразу переходит к слайду 3 с тремя вопросами для разогрева. Если читатель проходит лекцию в self-study режиме — этот слайд можно пропускать сразу после фиксации того, что это четвёртая лекция курса «AI в разных индустриях».</a:t>
+              <a:t>Это титульный слайд лекции. Он короткий по смыслу: курс, номер лекции, тема, длительность, дата. Шаблон визуально совпадает с другими лекциями курса — это часть continuity, к которой студент уже привык. Никакого дополнительного контента здесь нет; задача слайда — обозначить точку входа в лекцию и быстро перейти к опросу. Лектор задерживается на нём ровно столько, сколько нужно, чтобы аудитория сориентировалась, и сразу переходит к слайду 3 с тремя вопросами для разогрева. Если читатель проходит лекцию в self-study режиме — этот слайд можно пропускать сразу после фиксации того, что это Лекция 7 курса «AI в разных индустриях» и четвёртая отраслевая лекция (разработка ПО → финансы → инженерное проектирование → медицина).</a:t>
             </a:r>
           </a:p>
         </p:txBody>
@@ -2517,13 +2517,13 @@
           <a:p/>
           <a:p>
             <a:r>
-              <a:t>Структура заключения. Сначала — три главных вывода лекции: AI-диагностика работает, разработка лекарств — частично, ответственность остаётся на враче. Это не финальный синтез, это заготовка для черновика чек-листа, который вы будете дополнять на Лекции 9 по этике.</a:t>
+              <a:t>Структура заключения. Сначала — три главных вывода лекции: AI-диагностика работает, разработка лекарств — частично, ответственность остаётся на враче. Это не финальный синтез, это сырьё для копилки персонального чек-листа, который вы соберёте на финальной Лекции 17 «Систематизация знаний и навыков».</a:t>
             </a:r>
           </a:p>
           <a:p/>
           <a:p>
             <a:r>
-              <a:t>Затем — закрывающая фраза, возврат к центральному вопросу. И тизер Лекции 6 про производство и сельское хозяйство — где AI работает в другом физическом окружении, на другом масштабе и с другими ставками.</a:t>
+              <a:t>Затем — закрывающая фраза, возврат к центральному вопросу. И взгляд вперёд: медицина — четвёртая отраслевая лекция, отраслевой тур продолжается дальше в другие индустрии, где ставки другие, но методологические принципы переносятся.</a:t>
             </a:r>
           </a:p>
           <a:p/>
@@ -2611,7 +2611,7 @@
           <a:p/>
           <a:p>
             <a:r>
-              <a:t>Третий. Ответственность — на враче. AI подсказывает, врач решает. Инженер строит систему так, чтобы responsibility была технически выполнима: transparency и калибровка confidence, audit-trail, деперсонализация данных, post-market monitoring. Конкретные три принципа — transparency + calibration; validation set покрывает deployment population; audit-trail + post-market monitoring — это input для черновика чек-листа на лекции 9 «Этика и регулирование». Не финальный синтез — input. Если в одной фразе: врач ставит диагноз, AI подсказывает, инженер делает так, чтобы врач мог по-настоящему решать.</a:t>
+              <a:t>Третий. Ответственность — на враче. AI подсказывает, врач решает. Инженер строит систему так, чтобы responsibility была технически выполнима: transparency и калибровка confidence, audit-trail, деперсонализация данных, post-market monitoring. Конкретные три принципа — transparency + calibration; validation set покрывает deployment population; audit-trail + post-market monitoring — это вход в копилку персонального чек-листа. Не финальный синтез — сырьё; финал собирается на Лекции 17 «Систематизация знаний и навыков» из всех отраслевых кейсов курса. Если в одной фразе: врач ставит диагноз, AI подсказывает, инженер делает так, чтобы врач мог по-настоящему решать.</a:t>
             </a:r>
           </a:p>
         </p:txBody>
@@ -2763,19 +2763,13 @@
           <a:lstStyle/>
           <a:p>
             <a:r>
-              <a:t>Следующее занятие по расписанию курса — Коллоквиум 1, пятая лекция, охватывающий первые четыре содержательные лекции: введение, AI в разработке ПО, AI в финансах и ритейле, AI в медицине. Коллоквиум включает тестовую часть на классификацию AI-технологий и письменный мини-кейс по триаде «Проблема — Результат — Ограничение». Подготовка к коллоквиуму — это в первую очередь повторение четырёх предыдущих глав методички, включая эту.</a:t>
+              <a:t>Медицина — четвёртая отраслевая лекция курса: отраслевой блок начинается с разработки программного обеспечения, затем финансы и ритейл, затем инженерное проектирование, и теперь медицина — индустрия с наивысшими ставками, человеческой жизнью. Дальше отраслевой тур продолжается. Мы будем переходить в другие индустрии, где ставки качественно другие: не пациент, а оборудование, урожай, инфраструктура. Но многие методологические принципы этой лекции переносятся напрямую — валидация модели на разных популяциях, прозрачность и интерпретируемость выхода, мониторинг качества после развёртывания. Стоимость ошибки меняется от индустрии к индустрии, а инженерная дисциплина оценки AI — нет.</a:t>
             </a:r>
           </a:p>
           <a:p/>
           <a:p>
             <a:r>
-              <a:t>После Коллоквиума 1 — Лекция 6 «AI в производстве и сельском хозяйстве». Здесь главный российский кейс — Cognitive Agro Pilot, более полутора тысяч машин в работе, заявленный прирост эффективности тридцать-сорок процентов. Кроме сельского хозяйства, мы посмотрим predictive maintenance, quality control, collaborative robots, физический AI: дроны-инспекторы, автономный транспорт, digital twins. Из ячейки «медицина» движемся в ячейку «производство»; ставки другие — не пациент, а оборудование и урожай — но многие методологические принципы переносятся: валидация на разных популяциях, transparency, post-market monitoring.</a:t>
-            </a:r>
-          </a:p>
-          <a:p/>
-          <a:p>
-            <a:r>
-              <a:t>И ещё одна важная связь forward. Три принципа responsibility, которые мы сформулировали сегодня — transparency и калибровка; validation set покрывает deployment population; audit-trail и post-market monitoring — это не финальный синтез, а input для черновика чек-листа, который вы создадите на Лекции 9 «Этика и регулирование». На Лекции 14 «Будущее AI» вы превратите этот черновик в personal версию чек-листа из трёх-пяти пунктов. Опциональное домашнее задание для тех, у кого есть время: найти один случай medical AI в новостях за последний месяц (Reuters, STAT News, Habr) и применить к нему 4-actor framework со слайда 24. Не оценивается; для тренировки навыка применения.</a:t>
+              <a:t>Самое важное, что нужно унести с этой лекции, — три наблюдения об ответственном использовании AI в медицине. Первое: AI-выход должен быть интерпретируемым, а его confidence score — калибровано-проверенным. Второе: валидационный датасет должен покрывать ту популяцию, на которой модель реально работает; bias тестируется явно. Третье: должны быть audit-trail и постоянный мониторинг качества в production. Это не финальный синтез — это сырьё, вход в копилку вашего персонального чек-листа ответственного использования AI. Финал собирается не сегодня и не на следующей лекции, а на финальной Лекции 17 «Систематизация знаний и навыков», где вы будете синтезировать чек-лист из всех отраслевых кейсов курса, а не из одного. Один такой кейс — медицинский — у вас теперь есть.</a:t>
             </a:r>
           </a:p>
         </p:txBody>
@@ -18206,7 +18200,7 @@
                 </a:solidFill>
                 <a:latin typeface="Arial"/>
               </a:rPr>
-              <a:t>04</a:t>
+              <a:t>07</a:t>
             </a:r>
           </a:p>
         </p:txBody>
@@ -31066,7 +31060,7 @@
                 </a:solidFill>
                 <a:latin typeface="Arial"/>
               </a:rPr>
-              <a:t>3 наблюдения · тизер Лекции 6 · Q&amp;A</a:t>
+              <a:t>3 наблюдения · что дальше · Q&amp;A</a:t>
             </a:r>
           </a:p>
         </p:txBody>
@@ -33308,7 +33302,7 @@
                 </a:solidFill>
                 <a:latin typeface="Arial"/>
               </a:rPr>
-              <a:t>3 принципа → черновик чек-листа</a:t>
+              <a:t>3 принципа → копилка для синтеза</a:t>
             </a:r>
           </a:p>
         </p:txBody>
@@ -33393,7 +33387,7 @@
                 </a:solidFill>
                 <a:latin typeface="Arial"/>
               </a:rPr>
-              <a:t>Личная версия → Лекция 14</a:t>
+              <a:t>Финал — Лекция 17</a:t>
             </a:r>
           </a:p>
         </p:txBody>
@@ -33480,7 +33474,7 @@
                 </a:solidFill>
                 <a:latin typeface="Arial"/>
               </a:rPr>
-              <a:t>→ 3 вывода = заготовка для черновика чек-листа на следующей лекции. Не финальный синтез — заготовка.</a:t>
+              <a:t>→ 3 вывода = сырьё для копилки чек-листа. Не финальный синтез — финал на Лекции 17.</a:t>
             </a:r>
           </a:p>
         </p:txBody>
@@ -33795,7 +33789,7 @@
                 </a:solidFill>
                 <a:latin typeface="Arial"/>
               </a:rPr>
-              <a:t>Что дальше: Лекция 6 + черновик чек-листа.</a:t>
+              <a:t>Что дальше: место медицины в туре + копилка для синтеза.</a:t>
             </a:r>
           </a:p>
         </p:txBody>
@@ -33834,7 +33828,7 @@
                 </a:solidFill>
                 <a:latin typeface="Arial"/>
               </a:rPr>
-              <a:t>3 принципа сегодня — основа для черновика чек-листа на следующей лекции по этике.</a:t>
+              <a:t>Медицина — четвёртая отраслевая лекция; принципы переносятся, финал синтеза — на Лекции 17.</a:t>
             </a:r>
           </a:p>
         </p:txBody>
@@ -33847,12 +33841,12 @@
         </p:nvSpPr>
         <p:spPr>
           <a:xfrm>
-            <a:off x="502920" y="2011680"/>
-            <a:ext cx="5486400" cy="3291840"/>
+            <a:off x="502920" y="1874519"/>
+            <a:ext cx="5486400" cy="3703320"/>
           </a:xfrm>
           <a:prstGeom prst="roundRect">
             <a:avLst>
-              <a:gd name="adj" fmla="val 9259"/>
+              <a:gd name="adj" fmla="val 8230"/>
             </a:avLst>
           </a:prstGeom>
           <a:solidFill>
@@ -33889,7 +33883,7 @@
       </p:sp>
       <p:pic>
         <p:nvPicPr>
-          <p:cNvPr id="5" name="Picture 4" descr="s28-agriculture.jpg"/>
+          <p:cNvPr id="5" name="Picture 4" descr="lucide-trending-up-blue.png"/>
           <p:cNvPicPr>
             <a:picLocks noChangeAspect="1"/>
           </p:cNvPicPr>
@@ -33903,8 +33897,8 @@
         </p:blipFill>
         <p:spPr>
           <a:xfrm>
-            <a:off x="1986280" y="2240280"/>
-            <a:ext cx="2519680" cy="1417320"/>
+            <a:off x="777240" y="2167127"/>
+            <a:ext cx="777240" cy="777240"/>
           </a:xfrm>
           <a:prstGeom prst="rect">
             <a:avLst/>
@@ -33919,7 +33913,181 @@
         </p:nvSpPr>
         <p:spPr>
           <a:xfrm>
+            <a:off x="1691640" y="2258568"/>
+            <a:ext cx="3611880" cy="594360"/>
+          </a:xfrm>
+          <a:prstGeom prst="rect">
+            <a:avLst/>
+          </a:prstGeom>
+          <a:noFill/>
+        </p:spPr>
+        <p:txBody>
+          <a:bodyPr wrap="square" lIns="0" rIns="0" tIns="0" bIns="0" anchor="t">
+            <a:spAutoFit/>
+          </a:bodyPr>
+          <a:lstStyle/>
+          <a:p>
+            <a:pPr algn="l">
+              <a:lnSpc>
+                <a:spcPct val="115000"/>
+              </a:lnSpc>
+            </a:pPr>
+            <a:r>
+              <a:rPr sz="1800" b="1" i="0">
+                <a:solidFill>
+                  <a:srgbClr val="21295C"/>
+                </a:solidFill>
+                <a:latin typeface="Arial"/>
+              </a:rPr>
+              <a:t>Где мы в отраслевом туре</a:t>
+            </a:r>
+          </a:p>
+        </p:txBody>
+      </p:sp>
+      <p:sp>
+        <p:nvSpPr>
+          <p:cNvPr id="7" name="TextBox 6"/>
+          <p:cNvSpPr txBox="1"/>
+          <p:nvPr/>
+        </p:nvSpPr>
+        <p:spPr>
+          <a:xfrm>
+            <a:off x="777240" y="3154679"/>
+            <a:ext cx="4937760" cy="502920"/>
+          </a:xfrm>
+          <a:prstGeom prst="rect">
+            <a:avLst/>
+          </a:prstGeom>
+          <a:noFill/>
+        </p:spPr>
+        <p:txBody>
+          <a:bodyPr wrap="square" lIns="0" rIns="0" tIns="0" bIns="0" anchor="t">
+            <a:spAutoFit/>
+          </a:bodyPr>
+          <a:lstStyle/>
+          <a:p>
+            <a:pPr algn="l">
+              <a:lnSpc>
+                <a:spcPct val="120000"/>
+              </a:lnSpc>
+            </a:pPr>
+            <a:r>
+              <a:rPr sz="1400" b="0" i="0">
+                <a:solidFill>
+                  <a:srgbClr val="21295C"/>
+                </a:solidFill>
+                <a:latin typeface="Arial"/>
+              </a:rPr>
+              <a:t>Медицина — </a:t>
+            </a:r>
+            <a:r>
+              <a:rPr sz="1400" b="1" i="0">
+                <a:solidFill>
+                  <a:srgbClr val="F0AB00"/>
+                </a:solidFill>
+                <a:latin typeface="Arial"/>
+              </a:rPr>
+              <a:t>четвёртая отраслевая лекция</a:t>
+            </a:r>
+            <a:r>
+              <a:rPr sz="1400" b="0" i="0">
+                <a:solidFill>
+                  <a:srgbClr val="21295C"/>
+                </a:solidFill>
+                <a:latin typeface="Arial"/>
+              </a:rPr>
+              <a:t>.</a:t>
+            </a:r>
+          </a:p>
+        </p:txBody>
+      </p:sp>
+      <p:sp>
+        <p:nvSpPr>
+          <p:cNvPr id="8" name="TextBox 7"/>
+          <p:cNvSpPr txBox="1"/>
+          <p:nvPr/>
+        </p:nvSpPr>
+        <p:spPr>
+          <a:xfrm>
             <a:off x="777240" y="3657600"/>
+            <a:ext cx="4937760" cy="411480"/>
+          </a:xfrm>
+          <a:prstGeom prst="rect">
+            <a:avLst/>
+          </a:prstGeom>
+          <a:noFill/>
+        </p:spPr>
+        <p:txBody>
+          <a:bodyPr wrap="square" lIns="0" rIns="0" tIns="0" bIns="0" anchor="t">
+            <a:spAutoFit/>
+          </a:bodyPr>
+          <a:lstStyle/>
+          <a:p>
+            <a:pPr algn="l">
+              <a:lnSpc>
+                <a:spcPct val="120000"/>
+              </a:lnSpc>
+            </a:pPr>
+            <a:r>
+              <a:rPr sz="1200" b="0" i="1">
+                <a:solidFill>
+                  <a:srgbClr val="1C7293"/>
+                </a:solidFill>
+                <a:latin typeface="Arial"/>
+              </a:rPr>
+              <a:t>ПО → финансы → инженерное проектирование → медицина</a:t>
+            </a:r>
+          </a:p>
+        </p:txBody>
+      </p:sp>
+      <p:sp>
+        <p:nvSpPr>
+          <p:cNvPr id="9" name="TextBox 8"/>
+          <p:cNvSpPr txBox="1"/>
+          <p:nvPr/>
+        </p:nvSpPr>
+        <p:spPr>
+          <a:xfrm>
+            <a:off x="777240" y="4160520"/>
+            <a:ext cx="4937760" cy="1417320"/>
+          </a:xfrm>
+          <a:prstGeom prst="rect">
+            <a:avLst/>
+          </a:prstGeom>
+          <a:noFill/>
+        </p:spPr>
+        <p:txBody>
+          <a:bodyPr wrap="square" lIns="0" rIns="0" tIns="0" bIns="0" anchor="t">
+            <a:spAutoFit/>
+          </a:bodyPr>
+          <a:lstStyle/>
+          <a:p>
+            <a:pPr algn="l">
+              <a:lnSpc>
+                <a:spcPct val="135000"/>
+              </a:lnSpc>
+            </a:pPr>
+            <a:r>
+              <a:rPr sz="1300" b="0" i="0">
+                <a:solidFill>
+                  <a:srgbClr val="21295C"/>
+                </a:solidFill>
+                <a:latin typeface="Arial"/>
+              </a:rPr>
+              <a:t>Дальше тур продолжается — другие индустрии, где ставки другие: не пациент, а оборудование, урожай, инфраструктура.</a:t>
+            </a:r>
+          </a:p>
+        </p:txBody>
+      </p:sp>
+      <p:sp>
+        <p:nvSpPr>
+          <p:cNvPr id="10" name="TextBox 9"/>
+          <p:cNvSpPr txBox="1"/>
+          <p:nvPr/>
+        </p:nvSpPr>
+        <p:spPr>
+          <a:xfrm>
+            <a:off x="777240" y="5184648"/>
             <a:ext cx="4937760" cy="320040"/>
           </a:xfrm>
           <a:prstGeom prst="rect">
@@ -33935,161 +34103,35 @@
           <a:p>
             <a:pPr algn="l">
               <a:lnSpc>
-                <a:spcPct val="120000"/>
-              </a:lnSpc>
-            </a:pPr>
-            <a:r>
-              <a:rPr sz="1500" b="1" i="0">
-                <a:solidFill>
-                  <a:srgbClr val="21295C"/>
-                </a:solidFill>
-                <a:latin typeface="Arial"/>
-              </a:rPr>
-              <a:t>Лекция 6 — Производство и сельское хозяйство</a:t>
-            </a:r>
-          </a:p>
-        </p:txBody>
-      </p:sp>
-      <p:sp>
-        <p:nvSpPr>
-          <p:cNvPr id="7" name="TextBox 6"/>
-          <p:cNvSpPr txBox="1"/>
-          <p:nvPr/>
-        </p:nvSpPr>
-        <p:spPr>
-          <a:xfrm>
-            <a:off x="777240" y="3977639"/>
-            <a:ext cx="4937760" cy="365760"/>
-          </a:xfrm>
-          <a:prstGeom prst="rect">
-            <a:avLst/>
-          </a:prstGeom>
-          <a:noFill/>
-        </p:spPr>
-        <p:txBody>
-          <a:bodyPr wrap="square" lIns="0" rIns="0" tIns="0" bIns="0" anchor="t">
-            <a:spAutoFit/>
-          </a:bodyPr>
-          <a:lstStyle/>
-          <a:p>
-            <a:pPr algn="l">
-              <a:lnSpc>
                 <a:spcPct val="115000"/>
               </a:lnSpc>
             </a:pPr>
             <a:r>
-              <a:rPr sz="1300" b="1" i="0">
-                <a:solidFill>
-                  <a:srgbClr val="21295C"/>
-                </a:solidFill>
-                <a:latin typeface="Arial"/>
-              </a:rPr>
-              <a:t>Cognitive Agro Pilot — 1 500+ машин</a:t>
-            </a:r>
-          </a:p>
-        </p:txBody>
-      </p:sp>
-      <p:sp>
-        <p:nvSpPr>
-          <p:cNvPr id="8" name="TextBox 7"/>
-          <p:cNvSpPr txBox="1"/>
-          <p:nvPr/>
-        </p:nvSpPr>
-        <p:spPr>
-          <a:xfrm>
-            <a:off x="777240" y="4389120"/>
-            <a:ext cx="5029200" cy="411480"/>
-          </a:xfrm>
-          <a:prstGeom prst="rect">
-            <a:avLst/>
-          </a:prstGeom>
-          <a:noFill/>
-        </p:spPr>
-        <p:txBody>
-          <a:bodyPr wrap="square" lIns="0" rIns="0" tIns="0" bIns="0" anchor="ctr">
-            <a:spAutoFit/>
-          </a:bodyPr>
-          <a:lstStyle/>
-          <a:p>
-            <a:pPr algn="l">
-              <a:lnSpc>
-                <a:spcPct val="110000"/>
-              </a:lnSpc>
-            </a:pPr>
-            <a:r>
-              <a:rPr sz="2200" b="1" i="0">
-                <a:solidFill>
-                  <a:srgbClr val="F0AB00"/>
-                </a:solidFill>
-                <a:latin typeface="Arial"/>
-              </a:rPr>
-              <a:t>+30–40%</a:t>
-            </a:r>
-            <a:r>
               <a:rPr sz="1200" b="0" i="1">
                 <a:solidFill>
-                  <a:srgbClr val="21295C"/>
-                </a:solidFill>
-                <a:latin typeface="Arial"/>
-              </a:rPr>
-              <a:t>  эффективности (российский кейс)</a:t>
-            </a:r>
-          </a:p>
-        </p:txBody>
-      </p:sp>
-      <p:sp>
-        <p:nvSpPr>
-          <p:cNvPr id="9" name="TextBox 8"/>
-          <p:cNvSpPr txBox="1"/>
-          <p:nvPr/>
-        </p:nvSpPr>
-        <p:spPr>
-          <a:xfrm>
-            <a:off x="777240" y="4846320"/>
-            <a:ext cx="5029200" cy="320040"/>
-          </a:xfrm>
-          <a:prstGeom prst="rect">
-            <a:avLst/>
-          </a:prstGeom>
-          <a:noFill/>
-        </p:spPr>
-        <p:txBody>
-          <a:bodyPr wrap="square" lIns="0" rIns="0" tIns="0" bIns="0" anchor="t">
-            <a:spAutoFit/>
-          </a:bodyPr>
-          <a:lstStyle/>
-          <a:p>
-            <a:pPr algn="l">
-              <a:lnSpc>
-                <a:spcPct val="115000"/>
-              </a:lnSpc>
-            </a:pPr>
-            <a:r>
-              <a:rPr sz="1100" b="0" i="1">
-                <a:solidFill>
-                  <a:srgbClr val="1C7293"/>
-                </a:solidFill>
-                <a:latin typeface="Arial"/>
-              </a:rPr>
-              <a:t>Предиктивное обслуживание · контроль качества · физический AI</a:t>
-            </a:r>
-          </a:p>
-        </p:txBody>
-      </p:sp>
-      <p:sp>
-        <p:nvSpPr>
-          <p:cNvPr id="10" name="Rounded Rectangle 9"/>
+                  <a:srgbClr val="065A82"/>
+                </a:solidFill>
+                <a:latin typeface="Arial"/>
+              </a:rPr>
+              <a:t>Принципы переносятся: валидация · transparency · monitoring.</a:t>
+            </a:r>
+          </a:p>
+        </p:txBody>
+      </p:sp>
+      <p:sp>
+        <p:nvSpPr>
+          <p:cNvPr id="11" name="Rounded Rectangle 10"/>
           <p:cNvSpPr/>
           <p:nvPr/>
         </p:nvSpPr>
         <p:spPr>
           <a:xfrm>
-            <a:off x="6263640" y="2011680"/>
-            <a:ext cx="5486400" cy="3291840"/>
+            <a:off x="6263640" y="1874519"/>
+            <a:ext cx="5486400" cy="3703320"/>
           </a:xfrm>
           <a:prstGeom prst="roundRect">
             <a:avLst>
-              <a:gd name="adj" fmla="val 9259"/>
+              <a:gd name="adj" fmla="val 8230"/>
             </a:avLst>
           </a:prstGeom>
           <a:solidFill>
@@ -34126,7 +34168,7 @@
       </p:sp>
       <p:pic>
         <p:nvPicPr>
-          <p:cNvPr id="11" name="Picture 10" descr="lucide-arrow-right-circle-blue.png"/>
+          <p:cNvPr id="12" name="Picture 11" descr="lucide-list-checks-blue.png"/>
           <p:cNvPicPr>
             <a:picLocks noChangeAspect="1"/>
           </p:cNvPicPr>
@@ -34140,8 +34182,8 @@
         </p:blipFill>
         <p:spPr>
           <a:xfrm>
-            <a:off x="6537959" y="2331720"/>
-            <a:ext cx="914400" cy="914400"/>
+            <a:off x="6537959" y="2167127"/>
+            <a:ext cx="777240" cy="777240"/>
           </a:xfrm>
           <a:prstGeom prst="rect">
             <a:avLst/>
@@ -34150,14 +34192,14 @@
       </p:pic>
       <p:sp>
         <p:nvSpPr>
-          <p:cNvPr id="12" name="TextBox 11"/>
-          <p:cNvSpPr txBox="1"/>
-          <p:nvPr/>
-        </p:nvSpPr>
-        <p:spPr>
-          <a:xfrm>
-            <a:off x="7589519" y="2377440"/>
-            <a:ext cx="3977639" cy="548640"/>
+          <p:cNvPr id="13" name="TextBox 12"/>
+          <p:cNvSpPr txBox="1"/>
+          <p:nvPr/>
+        </p:nvSpPr>
+        <p:spPr>
+          <a:xfrm>
+            <a:off x="7452360" y="2258568"/>
+            <a:ext cx="4114800" cy="594360"/>
           </a:xfrm>
           <a:prstGeom prst="rect">
             <a:avLst/>
@@ -34172,31 +34214,77 @@
           <a:p>
             <a:pPr algn="l">
               <a:lnSpc>
-                <a:spcPct val="120000"/>
-              </a:lnSpc>
-            </a:pPr>
-            <a:r>
-              <a:rPr sz="1600" b="1" i="0">
+                <a:spcPct val="115000"/>
+              </a:lnSpc>
+            </a:pPr>
+            <a:r>
+              <a:rPr sz="1800" b="1" i="0">
                 <a:solidFill>
                   <a:srgbClr val="21295C"/>
                 </a:solidFill>
                 <a:latin typeface="Arial"/>
               </a:rPr>
-              <a:t>Лекция 9 — Этика и регулирование</a:t>
-            </a:r>
-          </a:p>
-        </p:txBody>
-      </p:sp>
-      <p:sp>
-        <p:nvSpPr>
-          <p:cNvPr id="13" name="TextBox 12"/>
-          <p:cNvSpPr txBox="1"/>
-          <p:nvPr/>
-        </p:nvSpPr>
-        <p:spPr>
-          <a:xfrm>
-            <a:off x="6537959" y="3383280"/>
-            <a:ext cx="5029200" cy="1371600"/>
+              <a:t>3 наблюдения → копилка</a:t>
+            </a:r>
+          </a:p>
+        </p:txBody>
+      </p:sp>
+      <p:sp>
+        <p:nvSpPr>
+          <p:cNvPr id="14" name="Rounded Rectangle 13"/>
+          <p:cNvSpPr/>
+          <p:nvPr/>
+        </p:nvSpPr>
+        <p:spPr>
+          <a:xfrm>
+            <a:off x="6537959" y="3172968"/>
+            <a:ext cx="100584" cy="100584"/>
+          </a:xfrm>
+          <a:prstGeom prst="roundRect">
+            <a:avLst>
+              <a:gd name="adj" fmla="val 50000"/>
+            </a:avLst>
+          </a:prstGeom>
+          <a:solidFill>
+            <a:srgbClr val="065A82"/>
+          </a:solidFill>
+          <a:ln>
+            <a:noFill/>
+          </a:ln>
+          <a:effectLst/>
+        </p:spPr>
+        <p:style>
+          <a:lnRef idx="1">
+            <a:schemeClr val="accent1"/>
+          </a:lnRef>
+          <a:fillRef idx="3">
+            <a:schemeClr val="accent1"/>
+          </a:fillRef>
+          <a:effectRef idx="2">
+            <a:schemeClr val="accent1"/>
+          </a:effectRef>
+          <a:fontRef idx="minor">
+            <a:schemeClr val="lt1"/>
+          </a:fontRef>
+        </p:style>
+        <p:txBody>
+          <a:bodyPr rtlCol="0" anchor="ctr"/>
+          <a:lstStyle/>
+          <a:p>
+            <a:pPr algn="ctr"/>
+          </a:p>
+        </p:txBody>
+      </p:sp>
+      <p:sp>
+        <p:nvSpPr>
+          <p:cNvPr id="15" name="TextBox 14"/>
+          <p:cNvSpPr txBox="1"/>
+          <p:nvPr/>
+        </p:nvSpPr>
+        <p:spPr>
+          <a:xfrm>
+            <a:off x="6766559" y="3108960"/>
+            <a:ext cx="4617720" cy="310896"/>
           </a:xfrm>
           <a:prstGeom prst="rect">
             <a:avLst/>
@@ -34211,19 +34299,430 @@
           <a:p>
             <a:pPr algn="l">
               <a:lnSpc>
-                <a:spcPct val="145000"/>
-              </a:lnSpc>
-            </a:pPr>
-            <a:r>
-              <a:rPr sz="1300" b="0" i="0">
+                <a:spcPct val="110000"/>
+              </a:lnSpc>
+            </a:pPr>
+            <a:r>
+              <a:rPr sz="1300" b="1" i="0">
                 <a:solidFill>
                   <a:srgbClr val="21295C"/>
                 </a:solidFill>
                 <a:latin typeface="Arial"/>
               </a:rPr>
-              <a:t>3 принципа сегодня
-→ черновик чек-листа на Лекции 9
-→ личная версия на Лекции 14</a:t>
+              <a:t>Transparency + calibration</a:t>
+            </a:r>
+          </a:p>
+        </p:txBody>
+      </p:sp>
+      <p:sp>
+        <p:nvSpPr>
+          <p:cNvPr id="16" name="TextBox 15"/>
+          <p:cNvSpPr txBox="1"/>
+          <p:nvPr/>
+        </p:nvSpPr>
+        <p:spPr>
+          <a:xfrm>
+            <a:off x="6766559" y="3419856"/>
+            <a:ext cx="4617720" cy="310896"/>
+          </a:xfrm>
+          <a:prstGeom prst="rect">
+            <a:avLst/>
+          </a:prstGeom>
+          <a:noFill/>
+        </p:spPr>
+        <p:txBody>
+          <a:bodyPr wrap="square" lIns="0" rIns="0" tIns="0" bIns="0" anchor="t">
+            <a:spAutoFit/>
+          </a:bodyPr>
+          <a:lstStyle/>
+          <a:p>
+            <a:pPr algn="l">
+              <a:lnSpc>
+                <a:spcPct val="110000"/>
+              </a:lnSpc>
+            </a:pPr>
+            <a:r>
+              <a:rPr sz="1100" b="0" i="1">
+                <a:solidFill>
+                  <a:srgbClr val="1C7293"/>
+                </a:solidFill>
+                <a:latin typeface="Arial"/>
+              </a:rPr>
+              <a:t>интерпретируемый выход; confidence калибровано-проверен</a:t>
+            </a:r>
+          </a:p>
+        </p:txBody>
+      </p:sp>
+      <p:sp>
+        <p:nvSpPr>
+          <p:cNvPr id="17" name="Rounded Rectangle 16"/>
+          <p:cNvSpPr/>
+          <p:nvPr/>
+        </p:nvSpPr>
+        <p:spPr>
+          <a:xfrm>
+            <a:off x="6537959" y="3886200"/>
+            <a:ext cx="100584" cy="100584"/>
+          </a:xfrm>
+          <a:prstGeom prst="roundRect">
+            <a:avLst>
+              <a:gd name="adj" fmla="val 50000"/>
+            </a:avLst>
+          </a:prstGeom>
+          <a:solidFill>
+            <a:srgbClr val="065A82"/>
+          </a:solidFill>
+          <a:ln>
+            <a:noFill/>
+          </a:ln>
+          <a:effectLst/>
+        </p:spPr>
+        <p:style>
+          <a:lnRef idx="1">
+            <a:schemeClr val="accent1"/>
+          </a:lnRef>
+          <a:fillRef idx="3">
+            <a:schemeClr val="accent1"/>
+          </a:fillRef>
+          <a:effectRef idx="2">
+            <a:schemeClr val="accent1"/>
+          </a:effectRef>
+          <a:fontRef idx="minor">
+            <a:schemeClr val="lt1"/>
+          </a:fontRef>
+        </p:style>
+        <p:txBody>
+          <a:bodyPr rtlCol="0" anchor="ctr"/>
+          <a:lstStyle/>
+          <a:p>
+            <a:pPr algn="ctr"/>
+          </a:p>
+        </p:txBody>
+      </p:sp>
+      <p:sp>
+        <p:nvSpPr>
+          <p:cNvPr id="18" name="TextBox 17"/>
+          <p:cNvSpPr txBox="1"/>
+          <p:nvPr/>
+        </p:nvSpPr>
+        <p:spPr>
+          <a:xfrm>
+            <a:off x="6766559" y="3822191"/>
+            <a:ext cx="4617720" cy="310896"/>
+          </a:xfrm>
+          <a:prstGeom prst="rect">
+            <a:avLst/>
+          </a:prstGeom>
+          <a:noFill/>
+        </p:spPr>
+        <p:txBody>
+          <a:bodyPr wrap="square" lIns="0" rIns="0" tIns="0" bIns="0" anchor="t">
+            <a:spAutoFit/>
+          </a:bodyPr>
+          <a:lstStyle/>
+          <a:p>
+            <a:pPr algn="l">
+              <a:lnSpc>
+                <a:spcPct val="110000"/>
+              </a:lnSpc>
+            </a:pPr>
+            <a:r>
+              <a:rPr sz="1300" b="1" i="0">
+                <a:solidFill>
+                  <a:srgbClr val="21295C"/>
+                </a:solidFill>
+                <a:latin typeface="Arial"/>
+              </a:rPr>
+              <a:t>Validation set покрывает deployment population</a:t>
+            </a:r>
+          </a:p>
+        </p:txBody>
+      </p:sp>
+      <p:sp>
+        <p:nvSpPr>
+          <p:cNvPr id="19" name="TextBox 18"/>
+          <p:cNvSpPr txBox="1"/>
+          <p:nvPr/>
+        </p:nvSpPr>
+        <p:spPr>
+          <a:xfrm>
+            <a:off x="6766559" y="4133087"/>
+            <a:ext cx="4617720" cy="310896"/>
+          </a:xfrm>
+          <a:prstGeom prst="rect">
+            <a:avLst/>
+          </a:prstGeom>
+          <a:noFill/>
+        </p:spPr>
+        <p:txBody>
+          <a:bodyPr wrap="square" lIns="0" rIns="0" tIns="0" bIns="0" anchor="t">
+            <a:spAutoFit/>
+          </a:bodyPr>
+          <a:lstStyle/>
+          <a:p>
+            <a:pPr algn="l">
+              <a:lnSpc>
+                <a:spcPct val="110000"/>
+              </a:lnSpc>
+            </a:pPr>
+            <a:r>
+              <a:rPr sz="1100" b="0" i="1">
+                <a:solidFill>
+                  <a:srgbClr val="1C7293"/>
+                </a:solidFill>
+                <a:latin typeface="Arial"/>
+              </a:rPr>
+              <a:t>bias тестируется явно; датасет репрезентативен</a:t>
+            </a:r>
+          </a:p>
+        </p:txBody>
+      </p:sp>
+      <p:sp>
+        <p:nvSpPr>
+          <p:cNvPr id="20" name="Rounded Rectangle 19"/>
+          <p:cNvSpPr/>
+          <p:nvPr/>
+        </p:nvSpPr>
+        <p:spPr>
+          <a:xfrm>
+            <a:off x="6537959" y="4599432"/>
+            <a:ext cx="100584" cy="100584"/>
+          </a:xfrm>
+          <a:prstGeom prst="roundRect">
+            <a:avLst>
+              <a:gd name="adj" fmla="val 50000"/>
+            </a:avLst>
+          </a:prstGeom>
+          <a:solidFill>
+            <a:srgbClr val="065A82"/>
+          </a:solidFill>
+          <a:ln>
+            <a:noFill/>
+          </a:ln>
+          <a:effectLst/>
+        </p:spPr>
+        <p:style>
+          <a:lnRef idx="1">
+            <a:schemeClr val="accent1"/>
+          </a:lnRef>
+          <a:fillRef idx="3">
+            <a:schemeClr val="accent1"/>
+          </a:fillRef>
+          <a:effectRef idx="2">
+            <a:schemeClr val="accent1"/>
+          </a:effectRef>
+          <a:fontRef idx="minor">
+            <a:schemeClr val="lt1"/>
+          </a:fontRef>
+        </p:style>
+        <p:txBody>
+          <a:bodyPr rtlCol="0" anchor="ctr"/>
+          <a:lstStyle/>
+          <a:p>
+            <a:pPr algn="ctr"/>
+          </a:p>
+        </p:txBody>
+      </p:sp>
+      <p:sp>
+        <p:nvSpPr>
+          <p:cNvPr id="21" name="TextBox 20"/>
+          <p:cNvSpPr txBox="1"/>
+          <p:nvPr/>
+        </p:nvSpPr>
+        <p:spPr>
+          <a:xfrm>
+            <a:off x="6766559" y="4535424"/>
+            <a:ext cx="4617720" cy="310896"/>
+          </a:xfrm>
+          <a:prstGeom prst="rect">
+            <a:avLst/>
+          </a:prstGeom>
+          <a:noFill/>
+        </p:spPr>
+        <p:txBody>
+          <a:bodyPr wrap="square" lIns="0" rIns="0" tIns="0" bIns="0" anchor="t">
+            <a:spAutoFit/>
+          </a:bodyPr>
+          <a:lstStyle/>
+          <a:p>
+            <a:pPr algn="l">
+              <a:lnSpc>
+                <a:spcPct val="110000"/>
+              </a:lnSpc>
+            </a:pPr>
+            <a:r>
+              <a:rPr sz="1300" b="1" i="0">
+                <a:solidFill>
+                  <a:srgbClr val="21295C"/>
+                </a:solidFill>
+                <a:latin typeface="Arial"/>
+              </a:rPr>
+              <a:t>Audit-trail + post-market monitoring</a:t>
+            </a:r>
+          </a:p>
+        </p:txBody>
+      </p:sp>
+      <p:sp>
+        <p:nvSpPr>
+          <p:cNvPr id="22" name="TextBox 21"/>
+          <p:cNvSpPr txBox="1"/>
+          <p:nvPr/>
+        </p:nvSpPr>
+        <p:spPr>
+          <a:xfrm>
+            <a:off x="6766559" y="4846320"/>
+            <a:ext cx="4617720" cy="310896"/>
+          </a:xfrm>
+          <a:prstGeom prst="rect">
+            <a:avLst/>
+          </a:prstGeom>
+          <a:noFill/>
+        </p:spPr>
+        <p:txBody>
+          <a:bodyPr wrap="square" lIns="0" rIns="0" tIns="0" bIns="0" anchor="t">
+            <a:spAutoFit/>
+          </a:bodyPr>
+          <a:lstStyle/>
+          <a:p>
+            <a:pPr algn="l">
+              <a:lnSpc>
+                <a:spcPct val="110000"/>
+              </a:lnSpc>
+            </a:pPr>
+            <a:r>
+              <a:rPr sz="1100" b="0" i="1">
+                <a:solidFill>
+                  <a:srgbClr val="1C7293"/>
+                </a:solidFill>
+                <a:latin typeface="Arial"/>
+              </a:rPr>
+              <a:t>кто/когда/какая версия восстановимо; качество мониторится</a:t>
+            </a:r>
+          </a:p>
+        </p:txBody>
+      </p:sp>
+      <p:sp>
+        <p:nvSpPr>
+          <p:cNvPr id="23" name="TextBox 22"/>
+          <p:cNvSpPr txBox="1"/>
+          <p:nvPr/>
+        </p:nvSpPr>
+        <p:spPr>
+          <a:xfrm>
+            <a:off x="6537959" y="5184648"/>
+            <a:ext cx="4937760" cy="320040"/>
+          </a:xfrm>
+          <a:prstGeom prst="rect">
+            <a:avLst/>
+          </a:prstGeom>
+          <a:noFill/>
+        </p:spPr>
+        <p:txBody>
+          <a:bodyPr wrap="square" lIns="0" rIns="0" tIns="0" bIns="0" anchor="t">
+            <a:spAutoFit/>
+          </a:bodyPr>
+          <a:lstStyle/>
+          <a:p>
+            <a:pPr algn="l">
+              <a:lnSpc>
+                <a:spcPct val="115000"/>
+              </a:lnSpc>
+            </a:pPr>
+            <a:r>
+              <a:rPr sz="1200" b="0" i="1">
+                <a:solidFill>
+                  <a:srgbClr val="065A82"/>
+                </a:solidFill>
+                <a:latin typeface="Arial"/>
+              </a:rPr>
+              <a:t>Это вход в копилку персонального чек-листа.</a:t>
+            </a:r>
+          </a:p>
+        </p:txBody>
+      </p:sp>
+      <p:sp>
+        <p:nvSpPr>
+          <p:cNvPr id="24" name="Rounded Rectangle 23"/>
+          <p:cNvSpPr/>
+          <p:nvPr/>
+        </p:nvSpPr>
+        <p:spPr>
+          <a:xfrm>
+            <a:off x="502920" y="5852160"/>
+            <a:ext cx="11247120" cy="502920"/>
+          </a:xfrm>
+          <a:prstGeom prst="roundRect">
+            <a:avLst>
+              <a:gd name="adj" fmla="val 12000"/>
+            </a:avLst>
+          </a:prstGeom>
+          <a:solidFill>
+            <a:srgbClr val="FEF5E0"/>
+          </a:solidFill>
+          <a:ln w="15240">
+            <a:solidFill>
+              <a:srgbClr val="F0AB00"/>
+            </a:solidFill>
+          </a:ln>
+          <a:effectLst/>
+        </p:spPr>
+        <p:style>
+          <a:lnRef idx="1">
+            <a:schemeClr val="accent1"/>
+          </a:lnRef>
+          <a:fillRef idx="3">
+            <a:schemeClr val="accent1"/>
+          </a:fillRef>
+          <a:effectRef idx="2">
+            <a:schemeClr val="accent1"/>
+          </a:effectRef>
+          <a:fontRef idx="minor">
+            <a:schemeClr val="lt1"/>
+          </a:fontRef>
+        </p:style>
+        <p:txBody>
+          <a:bodyPr rtlCol="0" anchor="ctr"/>
+          <a:lstStyle/>
+          <a:p>
+            <a:pPr algn="ctr"/>
+          </a:p>
+        </p:txBody>
+      </p:sp>
+      <p:sp>
+        <p:nvSpPr>
+          <p:cNvPr id="25" name="TextBox 24"/>
+          <p:cNvSpPr txBox="1"/>
+          <p:nvPr/>
+        </p:nvSpPr>
+        <p:spPr>
+          <a:xfrm>
+            <a:off x="685800" y="5925312"/>
+            <a:ext cx="10881360" cy="356616"/>
+          </a:xfrm>
+          <a:prstGeom prst="rect">
+            <a:avLst/>
+          </a:prstGeom>
+          <a:noFill/>
+        </p:spPr>
+        <p:txBody>
+          <a:bodyPr wrap="square" lIns="0" rIns="0" tIns="0" bIns="0" anchor="ctr">
+            <a:spAutoFit/>
+          </a:bodyPr>
+          <a:lstStyle/>
+          <a:p>
+            <a:pPr algn="l">
+              <a:lnSpc>
+                <a:spcPct val="125000"/>
+              </a:lnSpc>
+            </a:pPr>
+            <a:r>
+              <a:rPr sz="1300" b="1" i="0">
+                <a:solidFill>
+                  <a:srgbClr val="21295C"/>
+                </a:solidFill>
+                <a:latin typeface="Arial"/>
+              </a:rPr>
+              <a:t>Финал синтеза — Лекция 17 «Систематизация знаний и навыков»: сборка чек-листа из всех отраслевых кейсов курса.</a:t>
             </a:r>
           </a:p>
         </p:txBody>

</xml_diff>

<commit_message>
issue #162: Lecture 4 s13e — gloss "Honest Lying" (P1 from confirmatory presentation-critic pass)
Same defect class as the already-fixed "Presence paradox" gloss two lines above it on the same
slide. Confirmatory presentation-critic re-check found all 4 original REVISE-blocking P1s
resolved (gold-fill on s13d/s13f/s13g, table font 9.7->12pt on s13h, Presence-paradox gloss) but
caught this one remaining bare-English heading. Verdict after this fix: clears for GATE B.

Also evaluated (not applied): s13b's "structure + constraints + tests" pattern name — confirmed
this is a deck-wide established bare-English convention (originates on s09, repeated consistently
on s13b/s19/s25/s04a), not an isolated miss, so left as-is per house style.

Co-Authored-By: Claude Sonnet 5 <noreply@anthropic.com>
Claude-Session: https://claude.ai/code/session_01N71vxLEkJGTYpLwcDqoXje
</commit_message>
<xml_diff>
--- a/library/lectures/lec-04/rendered/lec-04.pptx
+++ b/library/lectures/lec-04/rendered/lec-04.pptx
@@ -1449,7 +1449,7 @@
           <a:p/>
           <a:p>
             <a:r>
-              <a:t>Есть и второй риск. Если агенту разрешено самому править свой steering-файл — «запиши, что понял по итогам сессии», — это то же уязвимое место, что написанные самим агентом (self-authored) заметки в целом. Исследование Honest Lying показало: такие заметки могут не исправлять неверное убеждение, а закреплять его через повторные попытки. Конкретный пример: агент на раннем шаге ошибочно записал в файл «тест X не проходит из-за Y» — следующая сессия унаследует эту запись как данность и не станет перепроверять её заново, даже когда реальная причина давно другая.</a:t>
+              <a:t>Есть и второй риск. Если агенту разрешено самому править свой steering-файл — «запиши, что понял по итогам сессии», — это то же уязвимое место, что написанные самим агентом (self-authored) заметки в целом. Исследование «Honest Lying» (правдоподобное самозакрепление ошибки) показало: такие заметки могут не исправлять неверное убеждение, а закреплять его через повторные попытки. Конкретный пример: агент на раннем шаге ошибочно записал в файл «тест X не проходит из-за Y» — следующая сессия унаследует эту запись как данность и не станет перепроверять её заново, даже когда реальная причина давно другая.</a:t>
             </a:r>
           </a:p>
           <a:p/>
@@ -17978,13 +17978,13 @@
               </a:lnSpc>
             </a:pPr>
             <a:r>
-              <a:rPr sz="1300" b="1" i="0">
+              <a:rPr sz="1200" b="1" i="0">
                 <a:solidFill>
                   <a:srgbClr val="065A82"/>
                 </a:solidFill>
                 <a:latin typeface="Arial"/>
               </a:rPr>
-              <a:t>Honest Lying: риск самостоятельной правки агентом</a:t>
+              <a:t>«Honest Lying» (правдоподобное самозакрепление ошибки): риск самостоятельной правки агентом</a:t>
             </a:r>
           </a:p>
         </p:txBody>

</xml_diff>